<commit_message>
fix(templates): mise en page tableau principal Template_16_1J
Formes bleues en arriere-plan dans les ecarts de matchs du template 16 equipes 1 jour.

Co-authored-by: Cursor <cursoragent@cursor.com>
</commit_message>
<xml_diff>
--- a/templates bleus/Template_16_1J.pptx
+++ b/templates bleus/Template_16_1J.pptx
@@ -218,7 +218,7 @@
           <a:p>
             <a:fld id="{7758DB49-402F-FB41-B58E-980CBE386162}" type="datetimeFigureOut">
               <a:rPr lang="fr-FR" smtClean="0"/>
-              <a:t>03/07/2026</a:t>
+              <a:t>06/07/2026</a:t>
             </a:fld>
             <a:endParaRPr lang="fr-FR"/>
           </a:p>
@@ -664,7 +664,7 @@
           <a:p>
             <a:fld id="{5BCAD085-E8A6-8845-BD4E-CB4CCA059FC4}" type="datetimeFigureOut">
               <a:rPr lang="en-US" smtClean="0"/>
-              <a:t>7/3/26</a:t>
+              <a:t>7/6/26</a:t>
             </a:fld>
             <a:endParaRPr lang="en-US"/>
           </a:p>
@@ -832,7 +832,7 @@
           <a:p>
             <a:fld id="{5BCAD085-E8A6-8845-BD4E-CB4CCA059FC4}" type="datetimeFigureOut">
               <a:rPr lang="en-US" smtClean="0"/>
-              <a:t>7/3/26</a:t>
+              <a:t>7/6/26</a:t>
             </a:fld>
             <a:endParaRPr lang="en-US"/>
           </a:p>
@@ -1010,7 +1010,7 @@
           <a:p>
             <a:fld id="{5BCAD085-E8A6-8845-BD4E-CB4CCA059FC4}" type="datetimeFigureOut">
               <a:rPr lang="en-US" smtClean="0"/>
-              <a:t>7/3/26</a:t>
+              <a:t>7/6/26</a:t>
             </a:fld>
             <a:endParaRPr lang="en-US"/>
           </a:p>
@@ -1178,7 +1178,7 @@
           <a:p>
             <a:fld id="{5BCAD085-E8A6-8845-BD4E-CB4CCA059FC4}" type="datetimeFigureOut">
               <a:rPr lang="en-US" smtClean="0"/>
-              <a:t>7/3/26</a:t>
+              <a:t>7/6/26</a:t>
             </a:fld>
             <a:endParaRPr lang="en-US"/>
           </a:p>
@@ -1423,7 +1423,7 @@
           <a:p>
             <a:fld id="{5BCAD085-E8A6-8845-BD4E-CB4CCA059FC4}" type="datetimeFigureOut">
               <a:rPr lang="en-US" smtClean="0"/>
-              <a:t>7/3/26</a:t>
+              <a:t>7/6/26</a:t>
             </a:fld>
             <a:endParaRPr lang="en-US"/>
           </a:p>
@@ -1708,7 +1708,7 @@
           <a:p>
             <a:fld id="{5BCAD085-E8A6-8845-BD4E-CB4CCA059FC4}" type="datetimeFigureOut">
               <a:rPr lang="en-US" smtClean="0"/>
-              <a:t>7/3/26</a:t>
+              <a:t>7/6/26</a:t>
             </a:fld>
             <a:endParaRPr lang="en-US"/>
           </a:p>
@@ -2127,7 +2127,7 @@
           <a:p>
             <a:fld id="{5BCAD085-E8A6-8845-BD4E-CB4CCA059FC4}" type="datetimeFigureOut">
               <a:rPr lang="en-US" smtClean="0"/>
-              <a:t>7/3/26</a:t>
+              <a:t>7/6/26</a:t>
             </a:fld>
             <a:endParaRPr lang="en-US"/>
           </a:p>
@@ -2244,7 +2244,7 @@
           <a:p>
             <a:fld id="{5BCAD085-E8A6-8845-BD4E-CB4CCA059FC4}" type="datetimeFigureOut">
               <a:rPr lang="en-US" smtClean="0"/>
-              <a:t>7/3/26</a:t>
+              <a:t>7/6/26</a:t>
             </a:fld>
             <a:endParaRPr lang="en-US"/>
           </a:p>
@@ -2339,7 +2339,7 @@
           <a:p>
             <a:fld id="{5BCAD085-E8A6-8845-BD4E-CB4CCA059FC4}" type="datetimeFigureOut">
               <a:rPr lang="en-US" smtClean="0"/>
-              <a:t>7/3/26</a:t>
+              <a:t>7/6/26</a:t>
             </a:fld>
             <a:endParaRPr lang="en-US"/>
           </a:p>
@@ -2614,7 +2614,7 @@
           <a:p>
             <a:fld id="{5BCAD085-E8A6-8845-BD4E-CB4CCA059FC4}" type="datetimeFigureOut">
               <a:rPr lang="en-US" smtClean="0"/>
-              <a:t>7/3/26</a:t>
+              <a:t>7/6/26</a:t>
             </a:fld>
             <a:endParaRPr lang="en-US"/>
           </a:p>
@@ -2866,7 +2866,7 @@
           <a:p>
             <a:fld id="{5BCAD085-E8A6-8845-BD4E-CB4CCA059FC4}" type="datetimeFigureOut">
               <a:rPr lang="en-US" smtClean="0"/>
-              <a:t>7/3/26</a:t>
+              <a:t>7/6/26</a:t>
             </a:fld>
             <a:endParaRPr lang="en-US"/>
           </a:p>
@@ -3077,7 +3077,7 @@
           <a:p>
             <a:fld id="{5BCAD085-E8A6-8845-BD4E-CB4CCA059FC4}" type="datetimeFigureOut">
               <a:rPr lang="en-US" smtClean="0"/>
-              <a:t>7/3/26</a:t>
+              <a:t>7/6/26</a:t>
             </a:fld>
             <a:endParaRPr lang="en-US"/>
           </a:p>
@@ -9876,215 +9876,19 @@
       </p:grpSpPr>
       <p:sp>
         <p:nvSpPr>
-          <p:cNvPr id="121" name="ZoneTexte 120">
-            <a:extLst>
-              <a:ext uri="{FF2B5EF4-FFF2-40B4-BE49-F238E27FC236}">
-                <a16:creationId xmlns:a16="http://schemas.microsoft.com/office/drawing/2014/main" id="{F4652EAC-16B7-2042-AB26-E5DE4DBD1890}"/>
-              </a:ext>
-            </a:extLst>
-          </p:cNvPr>
-          <p:cNvSpPr txBox="1"/>
+          <p:cNvPr id="165" name="Rounded Rectangle 2">
+            <a:extLst>
+              <a:ext uri="{FF2B5EF4-FFF2-40B4-BE49-F238E27FC236}">
+                <a16:creationId xmlns:a16="http://schemas.microsoft.com/office/drawing/2014/main" id="{710BB4D9-EAC3-ED4E-9DD0-B6331558BA9D}"/>
+              </a:ext>
+            </a:extLst>
+          </p:cNvPr>
+          <p:cNvSpPr/>
           <p:nvPr/>
         </p:nvSpPr>
         <p:spPr>
           <a:xfrm>
-            <a:off x="6834249" y="5300551"/>
-            <a:ext cx="2770519" cy="430887"/>
-          </a:xfrm>
-          <a:prstGeom prst="rect">
-            <a:avLst/>
-          </a:prstGeom>
-          <a:noFill/>
-        </p:spPr>
-        <p:txBody>
-          <a:bodyPr wrap="square" rtlCol="0">
-            <a:spAutoFit/>
-          </a:bodyPr>
-          <a:lstStyle/>
-          <a:p>
-            <a:pPr algn="ctr"/>
-            <a:r>
-              <a:rPr lang="fr-FR" sz="1100" b="1" dirty="0">
-                <a:solidFill>
-                  <a:schemeClr val="bg1"/>
-                </a:solidFill>
-                <a:latin typeface="Noto Sans" panose="020B0502040504020204" pitchFamily="34" charset="0"/>
-                <a:ea typeface="Noto Sans" panose="020B0502040504020204" pitchFamily="34" charset="0"/>
-                <a:cs typeface="Noto Sans" panose="020B0502040504020204" pitchFamily="34" charset="0"/>
-              </a:rPr>
-              <a:t>{{F_TERRAIN}}</a:t>
-            </a:r>
-          </a:p>
-          <a:p>
-            <a:pPr algn="ctr"/>
-            <a:endParaRPr lang="fr-FR" sz="1100" b="1" dirty="0">
-              <a:latin typeface="Noto Sans" panose="020B0502040504020204" pitchFamily="34" charset="0"/>
-              <a:ea typeface="Noto Sans" panose="020B0502040504020204" pitchFamily="34" charset="0"/>
-              <a:cs typeface="Noto Sans" panose="020B0502040504020204" pitchFamily="34" charset="0"/>
-            </a:endParaRPr>
-          </a:p>
-        </p:txBody>
-      </p:sp>
-      <p:sp>
-        <p:nvSpPr>
-          <p:cNvPr id="143" name="ZoneTexte 142">
-            <a:extLst>
-              <a:ext uri="{FF2B5EF4-FFF2-40B4-BE49-F238E27FC236}">
-                <a16:creationId xmlns:a16="http://schemas.microsoft.com/office/drawing/2014/main" id="{910BFB0A-ECDD-4B46-9FD8-3FCF5E218450}"/>
-              </a:ext>
-            </a:extLst>
-          </p:cNvPr>
-          <p:cNvSpPr txBox="1"/>
-          <p:nvPr/>
-        </p:nvSpPr>
-        <p:spPr>
-          <a:xfrm>
-            <a:off x="6818201" y="3063383"/>
-            <a:ext cx="2770523" cy="430887"/>
-          </a:xfrm>
-          <a:prstGeom prst="rect">
-            <a:avLst/>
-          </a:prstGeom>
-          <a:noFill/>
-        </p:spPr>
-        <p:txBody>
-          <a:bodyPr wrap="square" rtlCol="0">
-            <a:spAutoFit/>
-          </a:bodyPr>
-          <a:lstStyle/>
-          <a:p>
-            <a:pPr algn="ctr"/>
-            <a:r>
-              <a:rPr lang="fr-FR" sz="1100" b="1" dirty="0">
-                <a:solidFill>
-                  <a:schemeClr val="bg1"/>
-                </a:solidFill>
-                <a:latin typeface="Noto Sans" panose="020B0502040504020204" pitchFamily="34" charset="0"/>
-                <a:ea typeface="Noto Sans" panose="020B0502040504020204" pitchFamily="34" charset="0"/>
-                <a:cs typeface="Noto Sans" panose="020B0502040504020204" pitchFamily="34" charset="0"/>
-              </a:rPr>
-              <a:t>{{D1_TERRAIN}}</a:t>
-            </a:r>
-          </a:p>
-          <a:p>
-            <a:pPr algn="ctr"/>
-            <a:endParaRPr lang="fr-FR" sz="1100" b="1" dirty="0">
-              <a:latin typeface="Noto Sans" panose="020B0502040504020204" pitchFamily="34" charset="0"/>
-              <a:ea typeface="Noto Sans" panose="020B0502040504020204" pitchFamily="34" charset="0"/>
-              <a:cs typeface="Noto Sans" panose="020B0502040504020204" pitchFamily="34" charset="0"/>
-            </a:endParaRPr>
-          </a:p>
-        </p:txBody>
-      </p:sp>
-      <p:sp>
-        <p:nvSpPr>
-          <p:cNvPr id="99" name="ZoneTexte 98">
-            <a:extLst>
-              <a:ext uri="{FF2B5EF4-FFF2-40B4-BE49-F238E27FC236}">
-                <a16:creationId xmlns:a16="http://schemas.microsoft.com/office/drawing/2014/main" id="{48AD87D9-18D0-B640-BD6D-41EEB45F11B2}"/>
-              </a:ext>
-            </a:extLst>
-          </p:cNvPr>
-          <p:cNvSpPr txBox="1"/>
-          <p:nvPr/>
-        </p:nvSpPr>
-        <p:spPr>
-          <a:xfrm>
-            <a:off x="3558612" y="4589655"/>
-            <a:ext cx="2779641" cy="430887"/>
-          </a:xfrm>
-          <a:prstGeom prst="rect">
-            <a:avLst/>
-          </a:prstGeom>
-          <a:noFill/>
-        </p:spPr>
-        <p:txBody>
-          <a:bodyPr wrap="square" rtlCol="0">
-            <a:spAutoFit/>
-          </a:bodyPr>
-          <a:lstStyle/>
-          <a:p>
-            <a:pPr algn="ctr"/>
-            <a:r>
-              <a:rPr lang="fr-FR" sz="1100" b="1" dirty="0">
-                <a:solidFill>
-                  <a:schemeClr val="bg1"/>
-                </a:solidFill>
-                <a:latin typeface="Noto Sans" panose="020B0502040504020204" pitchFamily="34" charset="0"/>
-                <a:ea typeface="Noto Sans" panose="020B0502040504020204" pitchFamily="34" charset="0"/>
-                <a:cs typeface="Noto Sans" panose="020B0502040504020204" pitchFamily="34" charset="0"/>
-              </a:rPr>
-              <a:t>{{Q2_TERRAIN}}</a:t>
-            </a:r>
-          </a:p>
-          <a:p>
-            <a:pPr algn="ctr"/>
-            <a:endParaRPr lang="fr-FR" sz="1100" b="1" dirty="0">
-              <a:latin typeface="Noto Sans" panose="020B0502040504020204" pitchFamily="34" charset="0"/>
-              <a:ea typeface="Noto Sans" panose="020B0502040504020204" pitchFamily="34" charset="0"/>
-              <a:cs typeface="Noto Sans" panose="020B0502040504020204" pitchFamily="34" charset="0"/>
-            </a:endParaRPr>
-          </a:p>
-        </p:txBody>
-      </p:sp>
-      <p:sp>
-        <p:nvSpPr>
-          <p:cNvPr id="83" name="ZoneTexte 82">
-            <a:extLst>
-              <a:ext uri="{FF2B5EF4-FFF2-40B4-BE49-F238E27FC236}">
-                <a16:creationId xmlns:a16="http://schemas.microsoft.com/office/drawing/2014/main" id="{590F566A-D92F-5242-BBDC-F144A710434C}"/>
-              </a:ext>
-            </a:extLst>
-          </p:cNvPr>
-          <p:cNvSpPr txBox="1"/>
-          <p:nvPr/>
-        </p:nvSpPr>
-        <p:spPr>
-          <a:xfrm>
-            <a:off x="3558612" y="1446132"/>
-            <a:ext cx="2779639" cy="261610"/>
-          </a:xfrm>
-          <a:prstGeom prst="rect">
-            <a:avLst/>
-          </a:prstGeom>
-          <a:noFill/>
-        </p:spPr>
-        <p:txBody>
-          <a:bodyPr wrap="square" rtlCol="0">
-            <a:spAutoFit/>
-          </a:bodyPr>
-          <a:lstStyle/>
-          <a:p>
-            <a:pPr algn="ctr"/>
-            <a:r>
-              <a:rPr lang="fr-FR" sz="1100" b="1" dirty="0">
-                <a:solidFill>
-                  <a:schemeClr val="bg1"/>
-                </a:solidFill>
-                <a:latin typeface="Noto Sans" panose="020B0502040504020204" pitchFamily="34" charset="0"/>
-                <a:ea typeface="Noto Sans" panose="020B0502040504020204" pitchFamily="34" charset="0"/>
-                <a:cs typeface="Noto Sans" panose="020B0502040504020204" pitchFamily="34" charset="0"/>
-              </a:rPr>
-              <a:t>{{Q1_TERRAIN}}</a:t>
-            </a:r>
-          </a:p>
-        </p:txBody>
-      </p:sp>
-      <p:sp>
-        <p:nvSpPr>
-          <p:cNvPr id="159" name="Rounded Rectangle 2">
-            <a:extLst>
-              <a:ext uri="{FF2B5EF4-FFF2-40B4-BE49-F238E27FC236}">
-                <a16:creationId xmlns:a16="http://schemas.microsoft.com/office/drawing/2014/main" id="{FDF80FD5-6A2F-1A44-84B4-F2FD9CD739D3}"/>
-              </a:ext>
-            </a:extLst>
-          </p:cNvPr>
-          <p:cNvSpPr/>
-          <p:nvPr/>
-        </p:nvSpPr>
-        <p:spPr>
-          <a:xfrm>
-            <a:off x="329484" y="3833518"/>
+            <a:off x="6834244" y="5286427"/>
             <a:ext cx="2772945" cy="265527"/>
           </a:xfrm>
           <a:custGeom>
@@ -10338,10 +10142,10 @@
       </p:sp>
       <p:sp>
         <p:nvSpPr>
-          <p:cNvPr id="158" name="Rounded Rectangle 2">
-            <a:extLst>
-              <a:ext uri="{FF2B5EF4-FFF2-40B4-BE49-F238E27FC236}">
-                <a16:creationId xmlns:a16="http://schemas.microsoft.com/office/drawing/2014/main" id="{584582A1-F19D-1B42-8732-2B4B3C739BB0}"/>
+          <p:cNvPr id="164" name="Rounded Rectangle 2">
+            <a:extLst>
+              <a:ext uri="{FF2B5EF4-FFF2-40B4-BE49-F238E27FC236}">
+                <a16:creationId xmlns:a16="http://schemas.microsoft.com/office/drawing/2014/main" id="{877A799A-D27B-1A42-9BD7-75C6E2E46F58}"/>
               </a:ext>
             </a:extLst>
           </p:cNvPr>
@@ -10350,7 +10154,7 @@
         </p:nvSpPr>
         <p:spPr>
           <a:xfrm>
-            <a:off x="329484" y="2258645"/>
+            <a:off x="6824916" y="3050987"/>
             <a:ext cx="2772945" cy="265527"/>
           </a:xfrm>
           <a:custGeom>
@@ -10604,10 +10408,10 @@
       </p:sp>
       <p:sp>
         <p:nvSpPr>
-          <p:cNvPr id="160" name="Rounded Rectangle 2">
-            <a:extLst>
-              <a:ext uri="{FF2B5EF4-FFF2-40B4-BE49-F238E27FC236}">
-                <a16:creationId xmlns:a16="http://schemas.microsoft.com/office/drawing/2014/main" id="{4DE882FA-BE96-6B4A-BF36-4DFBD92E8BD2}"/>
+          <p:cNvPr id="161" name="Rounded Rectangle 2">
+            <a:extLst>
+              <a:ext uri="{FF2B5EF4-FFF2-40B4-BE49-F238E27FC236}">
+                <a16:creationId xmlns:a16="http://schemas.microsoft.com/office/drawing/2014/main" id="{D12134FA-D26C-144C-A14B-99A7659CB296}"/>
               </a:ext>
             </a:extLst>
           </p:cNvPr>
@@ -10616,7 +10420,7 @@
         </p:nvSpPr>
         <p:spPr>
           <a:xfrm>
-            <a:off x="324923" y="5416737"/>
+            <a:off x="3560751" y="4580798"/>
             <a:ext cx="2772945" cy="265527"/>
           </a:xfrm>
           <a:custGeom>
@@ -10870,10 +10674,10 @@
       </p:sp>
       <p:sp>
         <p:nvSpPr>
-          <p:cNvPr id="157" name="Rounded Rectangle 2">
-            <a:extLst>
-              <a:ext uri="{FF2B5EF4-FFF2-40B4-BE49-F238E27FC236}">
-                <a16:creationId xmlns:a16="http://schemas.microsoft.com/office/drawing/2014/main" id="{10E15BB4-066B-5245-8AA9-38153C09FEE8}"/>
+          <p:cNvPr id="162" name="Rounded Rectangle 2">
+            <a:extLst>
+              <a:ext uri="{FF2B5EF4-FFF2-40B4-BE49-F238E27FC236}">
+                <a16:creationId xmlns:a16="http://schemas.microsoft.com/office/drawing/2014/main" id="{471ADDD3-926F-974F-B0EF-C01E0CC69EB6}"/>
               </a:ext>
             </a:extLst>
           </p:cNvPr>
@@ -10882,7 +10686,7 @@
         </p:nvSpPr>
         <p:spPr>
           <a:xfrm>
-            <a:off x="335167" y="687178"/>
+            <a:off x="3560750" y="1429639"/>
             <a:ext cx="2772945" cy="265527"/>
           </a:xfrm>
           <a:custGeom>
@@ -11136,10 +10940,10 @@
       </p:sp>
       <p:sp>
         <p:nvSpPr>
-          <p:cNvPr id="67" name="ZoneTexte 66">
-            <a:extLst>
-              <a:ext uri="{FF2B5EF4-FFF2-40B4-BE49-F238E27FC236}">
-                <a16:creationId xmlns:a16="http://schemas.microsoft.com/office/drawing/2014/main" id="{243CB846-14FC-4C46-B83E-0B443436468B}"/>
+          <p:cNvPr id="121" name="ZoneTexte 120">
+            <a:extLst>
+              <a:ext uri="{FF2B5EF4-FFF2-40B4-BE49-F238E27FC236}">
+                <a16:creationId xmlns:a16="http://schemas.microsoft.com/office/drawing/2014/main" id="{F4652EAC-16B7-2042-AB26-E5DE4DBD1890}"/>
               </a:ext>
             </a:extLst>
           </p:cNvPr>
@@ -11148,8 +10952,8 @@
         </p:nvSpPr>
         <p:spPr>
           <a:xfrm>
-            <a:off x="331906" y="5431356"/>
-            <a:ext cx="2760299" cy="262800"/>
+            <a:off x="6834249" y="5300551"/>
+            <a:ext cx="2770519" cy="430887"/>
           </a:xfrm>
           <a:prstGeom prst="rect">
             <a:avLst/>
@@ -11172,17 +10976,25 @@
                 <a:ea typeface="Noto Sans" panose="020B0502040504020204" pitchFamily="34" charset="0"/>
                 <a:cs typeface="Noto Sans" panose="020B0502040504020204" pitchFamily="34" charset="0"/>
               </a:rPr>
-              <a:t>{{H4_TERRAIN}}</a:t>
+              <a:t>{{F_TERRAIN}}</a:t>
             </a:r>
+          </a:p>
+          <a:p>
+            <a:pPr algn="ctr"/>
+            <a:endParaRPr lang="fr-FR" sz="1100" b="1" dirty="0">
+              <a:latin typeface="Noto Sans" panose="020B0502040504020204" pitchFamily="34" charset="0"/>
+              <a:ea typeface="Noto Sans" panose="020B0502040504020204" pitchFamily="34" charset="0"/>
+              <a:cs typeface="Noto Sans" panose="020B0502040504020204" pitchFamily="34" charset="0"/>
+            </a:endParaRPr>
           </a:p>
         </p:txBody>
       </p:sp>
       <p:sp>
         <p:nvSpPr>
-          <p:cNvPr id="46" name="ZoneTexte 45">
-            <a:extLst>
-              <a:ext uri="{FF2B5EF4-FFF2-40B4-BE49-F238E27FC236}">
-                <a16:creationId xmlns:a16="http://schemas.microsoft.com/office/drawing/2014/main" id="{1949FF2A-29BE-8242-99DE-1A7686291175}"/>
+          <p:cNvPr id="143" name="ZoneTexte 142">
+            <a:extLst>
+              <a:ext uri="{FF2B5EF4-FFF2-40B4-BE49-F238E27FC236}">
+                <a16:creationId xmlns:a16="http://schemas.microsoft.com/office/drawing/2014/main" id="{910BFB0A-ECDD-4B46-9FD8-3FCF5E218450}"/>
               </a:ext>
             </a:extLst>
           </p:cNvPr>
@@ -11191,8 +11003,8 @@
         </p:nvSpPr>
         <p:spPr>
           <a:xfrm>
-            <a:off x="345600" y="3847463"/>
-            <a:ext cx="2756829" cy="261610"/>
+            <a:off x="6818201" y="3063383"/>
+            <a:ext cx="2770523" cy="430887"/>
           </a:xfrm>
           <a:prstGeom prst="rect">
             <a:avLst/>
@@ -11215,17 +11027,25 @@
                 <a:ea typeface="Noto Sans" panose="020B0502040504020204" pitchFamily="34" charset="0"/>
                 <a:cs typeface="Noto Sans" panose="020B0502040504020204" pitchFamily="34" charset="0"/>
               </a:rPr>
-              <a:t>{{H3_TERRAIN}}</a:t>
+              <a:t>{{D1_TERRAIN}}</a:t>
             </a:r>
+          </a:p>
+          <a:p>
+            <a:pPr algn="ctr"/>
+            <a:endParaRPr lang="fr-FR" sz="1100" b="1" dirty="0">
+              <a:latin typeface="Noto Sans" panose="020B0502040504020204" pitchFamily="34" charset="0"/>
+              <a:ea typeface="Noto Sans" panose="020B0502040504020204" pitchFamily="34" charset="0"/>
+              <a:cs typeface="Noto Sans" panose="020B0502040504020204" pitchFamily="34" charset="0"/>
+            </a:endParaRPr>
           </a:p>
         </p:txBody>
       </p:sp>
       <p:sp>
         <p:nvSpPr>
-          <p:cNvPr id="30" name="ZoneTexte 29">
-            <a:extLst>
-              <a:ext uri="{FF2B5EF4-FFF2-40B4-BE49-F238E27FC236}">
-                <a16:creationId xmlns:a16="http://schemas.microsoft.com/office/drawing/2014/main" id="{CB1A0634-4D40-F44E-96DD-90CAC34485C7}"/>
+          <p:cNvPr id="99" name="ZoneTexte 98">
+            <a:extLst>
+              <a:ext uri="{FF2B5EF4-FFF2-40B4-BE49-F238E27FC236}">
+                <a16:creationId xmlns:a16="http://schemas.microsoft.com/office/drawing/2014/main" id="{48AD87D9-18D0-B640-BD6D-41EEB45F11B2}"/>
               </a:ext>
             </a:extLst>
           </p:cNvPr>
@@ -11234,8 +11054,8 @@
         </p:nvSpPr>
         <p:spPr>
           <a:xfrm>
-            <a:off x="336471" y="2271000"/>
-            <a:ext cx="2756830" cy="430887"/>
+            <a:off x="3558612" y="4589655"/>
+            <a:ext cx="2779641" cy="430887"/>
           </a:xfrm>
           <a:prstGeom prst="rect">
             <a:avLst/>
@@ -11258,7 +11078,7 @@
                 <a:ea typeface="Noto Sans" panose="020B0502040504020204" pitchFamily="34" charset="0"/>
                 <a:cs typeface="Noto Sans" panose="020B0502040504020204" pitchFamily="34" charset="0"/>
               </a:rPr>
-              <a:t>{{H2_TERRAIN}}</a:t>
+              <a:t>{{Q2_TERRAIN}}</a:t>
             </a:r>
           </a:p>
           <a:p>
@@ -11273,10 +11093,10 @@
       </p:sp>
       <p:sp>
         <p:nvSpPr>
-          <p:cNvPr id="3" name="ZoneTexte 2">
-            <a:extLst>
-              <a:ext uri="{FF2B5EF4-FFF2-40B4-BE49-F238E27FC236}">
-                <a16:creationId xmlns:a16="http://schemas.microsoft.com/office/drawing/2014/main" id="{5F2AB4DE-8DC9-C241-AB61-34B919DD8121}"/>
+          <p:cNvPr id="83" name="ZoneTexte 82">
+            <a:extLst>
+              <a:ext uri="{FF2B5EF4-FFF2-40B4-BE49-F238E27FC236}">
+                <a16:creationId xmlns:a16="http://schemas.microsoft.com/office/drawing/2014/main" id="{590F566A-D92F-5242-BBDC-F144A710434C}"/>
               </a:ext>
             </a:extLst>
           </p:cNvPr>
@@ -11285,8 +11105,8 @@
         </p:nvSpPr>
         <p:spPr>
           <a:xfrm>
-            <a:off x="327342" y="702185"/>
-            <a:ext cx="2779651" cy="261610"/>
+            <a:off x="3558612" y="1446132"/>
+            <a:ext cx="2779639" cy="261610"/>
           </a:xfrm>
           <a:prstGeom prst="rect">
             <a:avLst/>
@@ -11309,17 +11129,17 @@
                 <a:ea typeface="Noto Sans" panose="020B0502040504020204" pitchFamily="34" charset="0"/>
                 <a:cs typeface="Noto Sans" panose="020B0502040504020204" pitchFamily="34" charset="0"/>
               </a:rPr>
-              <a:t>{{H1_TERRAIN}}</a:t>
+              <a:t>{{Q1_TERRAIN}}</a:t>
             </a:r>
           </a:p>
         </p:txBody>
       </p:sp>
       <p:sp>
         <p:nvSpPr>
-          <p:cNvPr id="165" name="Rounded Rectangle 2">
-            <a:extLst>
-              <a:ext uri="{FF2B5EF4-FFF2-40B4-BE49-F238E27FC236}">
-                <a16:creationId xmlns:a16="http://schemas.microsoft.com/office/drawing/2014/main" id="{710BB4D9-EAC3-ED4E-9DD0-B6331558BA9D}"/>
+          <p:cNvPr id="159" name="Rounded Rectangle 2">
+            <a:extLst>
+              <a:ext uri="{FF2B5EF4-FFF2-40B4-BE49-F238E27FC236}">
+                <a16:creationId xmlns:a16="http://schemas.microsoft.com/office/drawing/2014/main" id="{FDF80FD5-6A2F-1A44-84B4-F2FD9CD739D3}"/>
               </a:ext>
             </a:extLst>
           </p:cNvPr>
@@ -11328,7 +11148,7 @@
         </p:nvSpPr>
         <p:spPr>
           <a:xfrm>
-            <a:off x="6834244" y="5286427"/>
+            <a:off x="329484" y="3833518"/>
             <a:ext cx="2772945" cy="265527"/>
           </a:xfrm>
           <a:custGeom>
@@ -11582,10 +11402,10 @@
       </p:sp>
       <p:sp>
         <p:nvSpPr>
-          <p:cNvPr id="164" name="Rounded Rectangle 2">
-            <a:extLst>
-              <a:ext uri="{FF2B5EF4-FFF2-40B4-BE49-F238E27FC236}">
-                <a16:creationId xmlns:a16="http://schemas.microsoft.com/office/drawing/2014/main" id="{877A799A-D27B-1A42-9BD7-75C6E2E46F58}"/>
+          <p:cNvPr id="158" name="Rounded Rectangle 2">
+            <a:extLst>
+              <a:ext uri="{FF2B5EF4-FFF2-40B4-BE49-F238E27FC236}">
+                <a16:creationId xmlns:a16="http://schemas.microsoft.com/office/drawing/2014/main" id="{584582A1-F19D-1B42-8732-2B4B3C739BB0}"/>
               </a:ext>
             </a:extLst>
           </p:cNvPr>
@@ -11594,7 +11414,7 @@
         </p:nvSpPr>
         <p:spPr>
           <a:xfrm>
-            <a:off x="6824916" y="3050987"/>
+            <a:off x="329484" y="2258645"/>
             <a:ext cx="2772945" cy="265527"/>
           </a:xfrm>
           <a:custGeom>
@@ -11848,10 +11668,10 @@
       </p:sp>
       <p:sp>
         <p:nvSpPr>
-          <p:cNvPr id="162" name="Rounded Rectangle 2">
-            <a:extLst>
-              <a:ext uri="{FF2B5EF4-FFF2-40B4-BE49-F238E27FC236}">
-                <a16:creationId xmlns:a16="http://schemas.microsoft.com/office/drawing/2014/main" id="{471ADDD3-926F-974F-B0EF-C01E0CC69EB6}"/>
+          <p:cNvPr id="160" name="Rounded Rectangle 2">
+            <a:extLst>
+              <a:ext uri="{FF2B5EF4-FFF2-40B4-BE49-F238E27FC236}">
+                <a16:creationId xmlns:a16="http://schemas.microsoft.com/office/drawing/2014/main" id="{4DE882FA-BE96-6B4A-BF36-4DFBD92E8BD2}"/>
               </a:ext>
             </a:extLst>
           </p:cNvPr>
@@ -11860,7 +11680,7 @@
         </p:nvSpPr>
         <p:spPr>
           <a:xfrm>
-            <a:off x="3560750" y="1429639"/>
+            <a:off x="324923" y="5416737"/>
             <a:ext cx="2772945" cy="265527"/>
           </a:xfrm>
           <a:custGeom>
@@ -12114,10 +11934,10 @@
       </p:sp>
       <p:sp>
         <p:nvSpPr>
-          <p:cNvPr id="161" name="Rounded Rectangle 2">
-            <a:extLst>
-              <a:ext uri="{FF2B5EF4-FFF2-40B4-BE49-F238E27FC236}">
-                <a16:creationId xmlns:a16="http://schemas.microsoft.com/office/drawing/2014/main" id="{D12134FA-D26C-144C-A14B-99A7659CB296}"/>
+          <p:cNvPr id="157" name="Rounded Rectangle 2">
+            <a:extLst>
+              <a:ext uri="{FF2B5EF4-FFF2-40B4-BE49-F238E27FC236}">
+                <a16:creationId xmlns:a16="http://schemas.microsoft.com/office/drawing/2014/main" id="{10E15BB4-066B-5245-8AA9-38153C09FEE8}"/>
               </a:ext>
             </a:extLst>
           </p:cNvPr>
@@ -12126,7 +11946,7 @@
         </p:nvSpPr>
         <p:spPr>
           <a:xfrm>
-            <a:off x="3560751" y="4580798"/>
+            <a:off x="335167" y="687178"/>
             <a:ext cx="2772945" cy="265527"/>
           </a:xfrm>
           <a:custGeom>
@@ -12380,6 +12200,186 @@
       </p:sp>
       <p:sp>
         <p:nvSpPr>
+          <p:cNvPr id="67" name="ZoneTexte 66">
+            <a:extLst>
+              <a:ext uri="{FF2B5EF4-FFF2-40B4-BE49-F238E27FC236}">
+                <a16:creationId xmlns:a16="http://schemas.microsoft.com/office/drawing/2014/main" id="{243CB846-14FC-4C46-B83E-0B443436468B}"/>
+              </a:ext>
+            </a:extLst>
+          </p:cNvPr>
+          <p:cNvSpPr txBox="1"/>
+          <p:nvPr/>
+        </p:nvSpPr>
+        <p:spPr>
+          <a:xfrm>
+            <a:off x="331906" y="5431356"/>
+            <a:ext cx="2760299" cy="262800"/>
+          </a:xfrm>
+          <a:prstGeom prst="rect">
+            <a:avLst/>
+          </a:prstGeom>
+          <a:noFill/>
+        </p:spPr>
+        <p:txBody>
+          <a:bodyPr wrap="square" rtlCol="0">
+            <a:spAutoFit/>
+          </a:bodyPr>
+          <a:lstStyle/>
+          <a:p>
+            <a:pPr algn="ctr"/>
+            <a:r>
+              <a:rPr lang="fr-FR" sz="1100" b="1" dirty="0">
+                <a:solidFill>
+                  <a:schemeClr val="bg1"/>
+                </a:solidFill>
+                <a:latin typeface="Noto Sans" panose="020B0502040504020204" pitchFamily="34" charset="0"/>
+                <a:ea typeface="Noto Sans" panose="020B0502040504020204" pitchFamily="34" charset="0"/>
+                <a:cs typeface="Noto Sans" panose="020B0502040504020204" pitchFamily="34" charset="0"/>
+              </a:rPr>
+              <a:t>{{H4_TERRAIN}}</a:t>
+            </a:r>
+          </a:p>
+        </p:txBody>
+      </p:sp>
+      <p:sp>
+        <p:nvSpPr>
+          <p:cNvPr id="46" name="ZoneTexte 45">
+            <a:extLst>
+              <a:ext uri="{FF2B5EF4-FFF2-40B4-BE49-F238E27FC236}">
+                <a16:creationId xmlns:a16="http://schemas.microsoft.com/office/drawing/2014/main" id="{1949FF2A-29BE-8242-99DE-1A7686291175}"/>
+              </a:ext>
+            </a:extLst>
+          </p:cNvPr>
+          <p:cNvSpPr txBox="1"/>
+          <p:nvPr/>
+        </p:nvSpPr>
+        <p:spPr>
+          <a:xfrm>
+            <a:off x="345600" y="3847463"/>
+            <a:ext cx="2756829" cy="261610"/>
+          </a:xfrm>
+          <a:prstGeom prst="rect">
+            <a:avLst/>
+          </a:prstGeom>
+          <a:noFill/>
+        </p:spPr>
+        <p:txBody>
+          <a:bodyPr wrap="square" rtlCol="0">
+            <a:spAutoFit/>
+          </a:bodyPr>
+          <a:lstStyle/>
+          <a:p>
+            <a:pPr algn="ctr"/>
+            <a:r>
+              <a:rPr lang="fr-FR" sz="1100" b="1" dirty="0">
+                <a:solidFill>
+                  <a:schemeClr val="bg1"/>
+                </a:solidFill>
+                <a:latin typeface="Noto Sans" panose="020B0502040504020204" pitchFamily="34" charset="0"/>
+                <a:ea typeface="Noto Sans" panose="020B0502040504020204" pitchFamily="34" charset="0"/>
+                <a:cs typeface="Noto Sans" panose="020B0502040504020204" pitchFamily="34" charset="0"/>
+              </a:rPr>
+              <a:t>{{H3_TERRAIN}}</a:t>
+            </a:r>
+          </a:p>
+        </p:txBody>
+      </p:sp>
+      <p:sp>
+        <p:nvSpPr>
+          <p:cNvPr id="30" name="ZoneTexte 29">
+            <a:extLst>
+              <a:ext uri="{FF2B5EF4-FFF2-40B4-BE49-F238E27FC236}">
+                <a16:creationId xmlns:a16="http://schemas.microsoft.com/office/drawing/2014/main" id="{CB1A0634-4D40-F44E-96DD-90CAC34485C7}"/>
+              </a:ext>
+            </a:extLst>
+          </p:cNvPr>
+          <p:cNvSpPr txBox="1"/>
+          <p:nvPr/>
+        </p:nvSpPr>
+        <p:spPr>
+          <a:xfrm>
+            <a:off x="336471" y="2271000"/>
+            <a:ext cx="2756830" cy="430887"/>
+          </a:xfrm>
+          <a:prstGeom prst="rect">
+            <a:avLst/>
+          </a:prstGeom>
+          <a:noFill/>
+        </p:spPr>
+        <p:txBody>
+          <a:bodyPr wrap="square" rtlCol="0">
+            <a:spAutoFit/>
+          </a:bodyPr>
+          <a:lstStyle/>
+          <a:p>
+            <a:pPr algn="ctr"/>
+            <a:r>
+              <a:rPr lang="fr-FR" sz="1100" b="1" dirty="0">
+                <a:solidFill>
+                  <a:schemeClr val="bg1"/>
+                </a:solidFill>
+                <a:latin typeface="Noto Sans" panose="020B0502040504020204" pitchFamily="34" charset="0"/>
+                <a:ea typeface="Noto Sans" panose="020B0502040504020204" pitchFamily="34" charset="0"/>
+                <a:cs typeface="Noto Sans" panose="020B0502040504020204" pitchFamily="34" charset="0"/>
+              </a:rPr>
+              <a:t>{{H2_TERRAIN}}</a:t>
+            </a:r>
+          </a:p>
+          <a:p>
+            <a:pPr algn="ctr"/>
+            <a:endParaRPr lang="fr-FR" sz="1100" b="1" dirty="0">
+              <a:latin typeface="Noto Sans" panose="020B0502040504020204" pitchFamily="34" charset="0"/>
+              <a:ea typeface="Noto Sans" panose="020B0502040504020204" pitchFamily="34" charset="0"/>
+              <a:cs typeface="Noto Sans" panose="020B0502040504020204" pitchFamily="34" charset="0"/>
+            </a:endParaRPr>
+          </a:p>
+        </p:txBody>
+      </p:sp>
+      <p:sp>
+        <p:nvSpPr>
+          <p:cNvPr id="3" name="ZoneTexte 2">
+            <a:extLst>
+              <a:ext uri="{FF2B5EF4-FFF2-40B4-BE49-F238E27FC236}">
+                <a16:creationId xmlns:a16="http://schemas.microsoft.com/office/drawing/2014/main" id="{5F2AB4DE-8DC9-C241-AB61-34B919DD8121}"/>
+              </a:ext>
+            </a:extLst>
+          </p:cNvPr>
+          <p:cNvSpPr txBox="1"/>
+          <p:nvPr/>
+        </p:nvSpPr>
+        <p:spPr>
+          <a:xfrm>
+            <a:off x="327342" y="702185"/>
+            <a:ext cx="2779651" cy="261610"/>
+          </a:xfrm>
+          <a:prstGeom prst="rect">
+            <a:avLst/>
+          </a:prstGeom>
+          <a:noFill/>
+        </p:spPr>
+        <p:txBody>
+          <a:bodyPr wrap="square" rtlCol="0">
+            <a:spAutoFit/>
+          </a:bodyPr>
+          <a:lstStyle/>
+          <a:p>
+            <a:pPr algn="ctr"/>
+            <a:r>
+              <a:rPr lang="fr-FR" sz="1100" b="1" dirty="0">
+                <a:solidFill>
+                  <a:schemeClr val="bg1"/>
+                </a:solidFill>
+                <a:latin typeface="Noto Sans" panose="020B0502040504020204" pitchFamily="34" charset="0"/>
+                <a:ea typeface="Noto Sans" panose="020B0502040504020204" pitchFamily="34" charset="0"/>
+                <a:cs typeface="Noto Sans" panose="020B0502040504020204" pitchFamily="34" charset="0"/>
+              </a:rPr>
+              <a:t>{{H1_TERRAIN}}</a:t>
+            </a:r>
+          </a:p>
+        </p:txBody>
+      </p:sp>
+      <p:sp>
+        <p:nvSpPr>
           <p:cNvPr id="2" name="ZoneTexte 1">
             <a:extLst>
               <a:ext uri="{FF2B5EF4-FFF2-40B4-BE49-F238E27FC236}">
@@ -17233,7 +17233,7 @@
         </p:nvSpPr>
         <p:spPr>
           <a:xfrm>
-            <a:off x="6472885" y="2520000"/>
+            <a:off x="7144077" y="4776949"/>
             <a:ext cx="3383087" cy="523220"/>
           </a:xfrm>
           <a:prstGeom prst="rect">

</xml_diff>

<commit_message>
fix(templates): mise en page Template_16_1J (tableau principal)
Co-authored-by: Cursor <cursoragent@cursor.com>
</commit_message>
<xml_diff>
--- a/templates bleus/Template_16_1J.pptx
+++ b/templates bleus/Template_16_1J.pptx
@@ -3814,6 +3814,9 @@
             <a:pPr algn="ctr"/>
             <a:r>
               <a:rPr lang="fr-FR" sz="800" dirty="0" err="1">
+                <a:solidFill>
+                  <a:srgbClr val="FFFF00"/>
+                </a:solidFill>
                 <a:latin typeface="Grindy Brush" panose="02000500000000000000" pitchFamily="2" charset="0"/>
                 <a:ea typeface="Noto Sans" panose="020B0502040504020204" pitchFamily="34" charset="0"/>
                 <a:cs typeface="Noto Sans" panose="020B0502040504020204" pitchFamily="34" charset="0"/>
@@ -3822,6 +3825,9 @@
             </a:r>
             <a:r>
               <a:rPr lang="fr-FR" sz="800" dirty="0">
+                <a:solidFill>
+                  <a:srgbClr val="FFFF00"/>
+                </a:solidFill>
                 <a:latin typeface="Grindy Brush" panose="02000500000000000000" pitchFamily="2" charset="0"/>
                 <a:ea typeface="Noto Sans" panose="020B0502040504020204" pitchFamily="34" charset="0"/>
                 <a:cs typeface="Noto Sans" panose="020B0502040504020204" pitchFamily="34" charset="0"/>
@@ -3830,6 +3836,9 @@
             </a:r>
             <a:r>
               <a:rPr lang="fr-FR" sz="800" dirty="0" err="1">
+                <a:solidFill>
+                  <a:srgbClr val="FFFF00"/>
+                </a:solidFill>
                 <a:latin typeface="Grindy Brush" panose="02000500000000000000" pitchFamily="2" charset="0"/>
                 <a:ea typeface="Noto Sans" panose="020B0502040504020204" pitchFamily="34" charset="0"/>
                 <a:cs typeface="Noto Sans" panose="020B0502040504020204" pitchFamily="34" charset="0"/>
@@ -3838,6 +3847,9 @@
             </a:r>
             <a:r>
               <a:rPr lang="fr-FR" sz="800" dirty="0">
+                <a:solidFill>
+                  <a:srgbClr val="FFFF00"/>
+                </a:solidFill>
                 <a:latin typeface="Grindy Brush" panose="02000500000000000000" pitchFamily="2" charset="0"/>
                 <a:ea typeface="Noto Sans" panose="020B0502040504020204" pitchFamily="34" charset="0"/>
                 <a:cs typeface="Noto Sans" panose="020B0502040504020204" pitchFamily="34" charset="0"/>
@@ -3846,6 +3858,9 @@
             </a:r>
             <a:r>
               <a:rPr lang="fr-FR" sz="800" dirty="0" err="1">
+                <a:solidFill>
+                  <a:srgbClr val="FFFF00"/>
+                </a:solidFill>
                 <a:latin typeface="Grindy Brush" panose="02000500000000000000" pitchFamily="2" charset="0"/>
                 <a:ea typeface="Noto Sans" panose="020B0502040504020204" pitchFamily="34" charset="0"/>
                 <a:cs typeface="Noto Sans" panose="020B0502040504020204" pitchFamily="34" charset="0"/>
@@ -3854,6 +3869,9 @@
             </a:r>
             <a:r>
               <a:rPr lang="fr-FR" sz="800" dirty="0">
+                <a:solidFill>
+                  <a:srgbClr val="FFFF00"/>
+                </a:solidFill>
                 <a:latin typeface="Grindy Brush" panose="02000500000000000000" pitchFamily="2" charset="0"/>
                 <a:ea typeface="Noto Sans" panose="020B0502040504020204" pitchFamily="34" charset="0"/>
                 <a:cs typeface="Noto Sans" panose="020B0502040504020204" pitchFamily="34" charset="0"/>
@@ -3861,6 +3879,9 @@
               <a:t> </a:t>
             </a:r>
             <a:endParaRPr lang="fr-FR" sz="1100" dirty="0">
+              <a:solidFill>
+                <a:srgbClr val="FFFF00"/>
+              </a:solidFill>
               <a:latin typeface="Grindy Brush" panose="02000500000000000000" pitchFamily="2" charset="0"/>
               <a:ea typeface="Noto Sans" panose="020B0502040504020204" pitchFamily="34" charset="0"/>
               <a:cs typeface="Noto Sans" panose="020B0502040504020204" pitchFamily="34" charset="0"/>
@@ -9067,7 +9088,7 @@
           <p:nvPr>
             <p:extLst>
               <p:ext uri="{D42A27DB-BD31-4B8C-83A1-F6EECF244321}">
-                <p14:modId xmlns:p14="http://schemas.microsoft.com/office/powerpoint/2010/main" val="2495340480"/>
+                <p14:modId xmlns:p14="http://schemas.microsoft.com/office/powerpoint/2010/main" val="930833753"/>
               </p:ext>
             </p:extLst>
           </p:nvPr>

</xml_diff>

<commit_message>
fix(manager): PDF tab quality + reload Template_16_1J
Render live PDF pages at devicePixelRatio with print intent for sharp brush fonts and match boxes. Include updated 16-team 1-day template.

Co-authored-by: Cursor <cursoragent@cursor.com>
</commit_message>
<xml_diff>
--- a/templates bleus/Template_16_1J.pptx
+++ b/templates bleus/Template_16_1J.pptx
@@ -218,7 +218,7 @@
           <a:p>
             <a:fld id="{7758DB49-402F-FB41-B58E-980CBE386162}" type="datetimeFigureOut">
               <a:rPr lang="fr-FR" smtClean="0"/>
-              <a:t>06/07/2026</a:t>
+              <a:t>07/07/2026</a:t>
             </a:fld>
             <a:endParaRPr lang="fr-FR"/>
           </a:p>
@@ -664,7 +664,7 @@
           <a:p>
             <a:fld id="{5BCAD085-E8A6-8845-BD4E-CB4CCA059FC4}" type="datetimeFigureOut">
               <a:rPr lang="en-US" smtClean="0"/>
-              <a:t>7/6/26</a:t>
+              <a:t>7/7/26</a:t>
             </a:fld>
             <a:endParaRPr lang="en-US"/>
           </a:p>
@@ -832,7 +832,7 @@
           <a:p>
             <a:fld id="{5BCAD085-E8A6-8845-BD4E-CB4CCA059FC4}" type="datetimeFigureOut">
               <a:rPr lang="en-US" smtClean="0"/>
-              <a:t>7/6/26</a:t>
+              <a:t>7/7/26</a:t>
             </a:fld>
             <a:endParaRPr lang="en-US"/>
           </a:p>
@@ -1010,7 +1010,7 @@
           <a:p>
             <a:fld id="{5BCAD085-E8A6-8845-BD4E-CB4CCA059FC4}" type="datetimeFigureOut">
               <a:rPr lang="en-US" smtClean="0"/>
-              <a:t>7/6/26</a:t>
+              <a:t>7/7/26</a:t>
             </a:fld>
             <a:endParaRPr lang="en-US"/>
           </a:p>
@@ -1178,7 +1178,7 @@
           <a:p>
             <a:fld id="{5BCAD085-E8A6-8845-BD4E-CB4CCA059FC4}" type="datetimeFigureOut">
               <a:rPr lang="en-US" smtClean="0"/>
-              <a:t>7/6/26</a:t>
+              <a:t>7/7/26</a:t>
             </a:fld>
             <a:endParaRPr lang="en-US"/>
           </a:p>
@@ -1423,7 +1423,7 @@
           <a:p>
             <a:fld id="{5BCAD085-E8A6-8845-BD4E-CB4CCA059FC4}" type="datetimeFigureOut">
               <a:rPr lang="en-US" smtClean="0"/>
-              <a:t>7/6/26</a:t>
+              <a:t>7/7/26</a:t>
             </a:fld>
             <a:endParaRPr lang="en-US"/>
           </a:p>
@@ -1708,7 +1708,7 @@
           <a:p>
             <a:fld id="{5BCAD085-E8A6-8845-BD4E-CB4CCA059FC4}" type="datetimeFigureOut">
               <a:rPr lang="en-US" smtClean="0"/>
-              <a:t>7/6/26</a:t>
+              <a:t>7/7/26</a:t>
             </a:fld>
             <a:endParaRPr lang="en-US"/>
           </a:p>
@@ -2127,7 +2127,7 @@
           <a:p>
             <a:fld id="{5BCAD085-E8A6-8845-BD4E-CB4CCA059FC4}" type="datetimeFigureOut">
               <a:rPr lang="en-US" smtClean="0"/>
-              <a:t>7/6/26</a:t>
+              <a:t>7/7/26</a:t>
             </a:fld>
             <a:endParaRPr lang="en-US"/>
           </a:p>
@@ -2244,7 +2244,7 @@
           <a:p>
             <a:fld id="{5BCAD085-E8A6-8845-BD4E-CB4CCA059FC4}" type="datetimeFigureOut">
               <a:rPr lang="en-US" smtClean="0"/>
-              <a:t>7/6/26</a:t>
+              <a:t>7/7/26</a:t>
             </a:fld>
             <a:endParaRPr lang="en-US"/>
           </a:p>
@@ -2339,7 +2339,7 @@
           <a:p>
             <a:fld id="{5BCAD085-E8A6-8845-BD4E-CB4CCA059FC4}" type="datetimeFigureOut">
               <a:rPr lang="en-US" smtClean="0"/>
-              <a:t>7/6/26</a:t>
+              <a:t>7/7/26</a:t>
             </a:fld>
             <a:endParaRPr lang="en-US"/>
           </a:p>
@@ -2614,7 +2614,7 @@
           <a:p>
             <a:fld id="{5BCAD085-E8A6-8845-BD4E-CB4CCA059FC4}" type="datetimeFigureOut">
               <a:rPr lang="en-US" smtClean="0"/>
-              <a:t>7/6/26</a:t>
+              <a:t>7/7/26</a:t>
             </a:fld>
             <a:endParaRPr lang="en-US"/>
           </a:p>
@@ -2866,7 +2866,7 @@
           <a:p>
             <a:fld id="{5BCAD085-E8A6-8845-BD4E-CB4CCA059FC4}" type="datetimeFigureOut">
               <a:rPr lang="en-US" smtClean="0"/>
-              <a:t>7/6/26</a:t>
+              <a:t>7/7/26</a:t>
             </a:fld>
             <a:endParaRPr lang="en-US"/>
           </a:p>
@@ -3077,7 +3077,7 @@
           <a:p>
             <a:fld id="{5BCAD085-E8A6-8845-BD4E-CB4CCA059FC4}" type="datetimeFigureOut">
               <a:rPr lang="en-US" smtClean="0"/>
-              <a:t>7/6/26</a:t>
+              <a:t>7/7/26</a:t>
             </a:fld>
             <a:endParaRPr lang="en-US"/>
           </a:p>
@@ -24535,10 +24535,10 @@
       </p:grpSpPr>
       <p:sp>
         <p:nvSpPr>
-          <p:cNvPr id="69" name="Rounded Rectangle 2">
-            <a:extLst>
-              <a:ext uri="{FF2B5EF4-FFF2-40B4-BE49-F238E27FC236}">
-                <a16:creationId xmlns:a16="http://schemas.microsoft.com/office/drawing/2014/main" id="{82803C54-773B-4349-B14E-6F98BBB79F99}"/>
+          <p:cNvPr id="75" name="Rounded Rectangle 2">
+            <a:extLst>
+              <a:ext uri="{FF2B5EF4-FFF2-40B4-BE49-F238E27FC236}">
+                <a16:creationId xmlns:a16="http://schemas.microsoft.com/office/drawing/2014/main" id="{09E25820-F75D-F44E-8354-F6B818527754}"/>
               </a:ext>
             </a:extLst>
           </p:cNvPr>
@@ -24547,7 +24547,7 @@
         </p:nvSpPr>
         <p:spPr>
           <a:xfrm>
-            <a:off x="316080" y="3067824"/>
+            <a:off x="6807230" y="3048633"/>
             <a:ext cx="2772945" cy="265527"/>
           </a:xfrm>
           <a:custGeom>
@@ -24801,10 +24801,10 @@
       </p:sp>
       <p:sp>
         <p:nvSpPr>
-          <p:cNvPr id="77" name="Rounded Rectangle 2">
-            <a:extLst>
-              <a:ext uri="{FF2B5EF4-FFF2-40B4-BE49-F238E27FC236}">
-                <a16:creationId xmlns:a16="http://schemas.microsoft.com/office/drawing/2014/main" id="{B87ADA1F-E13A-5241-889E-9FD829CAD728}"/>
+          <p:cNvPr id="69" name="Rounded Rectangle 2">
+            <a:extLst>
+              <a:ext uri="{FF2B5EF4-FFF2-40B4-BE49-F238E27FC236}">
+                <a16:creationId xmlns:a16="http://schemas.microsoft.com/office/drawing/2014/main" id="{82803C54-773B-4349-B14E-6F98BBB79F99}"/>
               </a:ext>
             </a:extLst>
           </p:cNvPr>
@@ -24813,7 +24813,7 @@
         </p:nvSpPr>
         <p:spPr>
           <a:xfrm>
-            <a:off x="3566527" y="4577635"/>
+            <a:off x="316080" y="3067824"/>
             <a:ext cx="2772945" cy="265527"/>
           </a:xfrm>
           <a:custGeom>
@@ -25067,10 +25067,10 @@
       </p:sp>
       <p:sp>
         <p:nvSpPr>
-          <p:cNvPr id="76" name="Rounded Rectangle 2">
-            <a:extLst>
-              <a:ext uri="{FF2B5EF4-FFF2-40B4-BE49-F238E27FC236}">
-                <a16:creationId xmlns:a16="http://schemas.microsoft.com/office/drawing/2014/main" id="{71C495D7-526B-3B41-9395-A5783FC816DC}"/>
+          <p:cNvPr id="77" name="Rounded Rectangle 2">
+            <a:extLst>
+              <a:ext uri="{FF2B5EF4-FFF2-40B4-BE49-F238E27FC236}">
+                <a16:creationId xmlns:a16="http://schemas.microsoft.com/office/drawing/2014/main" id="{B87ADA1F-E13A-5241-889E-9FD829CAD728}"/>
               </a:ext>
             </a:extLst>
           </p:cNvPr>
@@ -25079,7 +25079,7 @@
         </p:nvSpPr>
         <p:spPr>
           <a:xfrm>
-            <a:off x="3563555" y="1430524"/>
+            <a:off x="3566527" y="4577635"/>
             <a:ext cx="2772945" cy="265527"/>
           </a:xfrm>
           <a:custGeom>
@@ -25333,235 +25333,19 @@
       </p:sp>
       <p:sp>
         <p:nvSpPr>
-          <p:cNvPr id="143" name="ZoneTexte 142">
-            <a:extLst>
-              <a:ext uri="{FF2B5EF4-FFF2-40B4-BE49-F238E27FC236}">
-                <a16:creationId xmlns:a16="http://schemas.microsoft.com/office/drawing/2014/main" id="{910BFB0A-ECDD-4B46-9FD8-3FCF5E218450}"/>
-              </a:ext>
-            </a:extLst>
-          </p:cNvPr>
-          <p:cNvSpPr txBox="1"/>
+          <p:cNvPr id="76" name="Rounded Rectangle 2">
+            <a:extLst>
+              <a:ext uri="{FF2B5EF4-FFF2-40B4-BE49-F238E27FC236}">
+                <a16:creationId xmlns:a16="http://schemas.microsoft.com/office/drawing/2014/main" id="{71C495D7-526B-3B41-9395-A5783FC816DC}"/>
+              </a:ext>
+            </a:extLst>
+          </p:cNvPr>
+          <p:cNvSpPr/>
           <p:nvPr/>
         </p:nvSpPr>
         <p:spPr>
           <a:xfrm>
-            <a:off x="7440224" y="3063383"/>
-            <a:ext cx="1414793" cy="430887"/>
-          </a:xfrm>
-          <a:prstGeom prst="rect">
-            <a:avLst/>
-          </a:prstGeom>
-          <a:noFill/>
-        </p:spPr>
-        <p:txBody>
-          <a:bodyPr wrap="square" rtlCol="0">
-            <a:spAutoFit/>
-          </a:bodyPr>
-          <a:lstStyle/>
-          <a:p>
-            <a:pPr algn="ctr"/>
-            <a:r>
-              <a:rPr lang="fr-FR" sz="1100" b="1" dirty="0">
-                <a:solidFill>
-                  <a:schemeClr val="bg1"/>
-                </a:solidFill>
-                <a:latin typeface="Noto Sans" panose="020B0502040504020204" pitchFamily="34" charset="0"/>
-                <a:ea typeface="Noto Sans" panose="020B0502040504020204" pitchFamily="34" charset="0"/>
-                <a:cs typeface="Noto Sans" panose="020B0502040504020204" pitchFamily="34" charset="0"/>
-              </a:rPr>
-              <a:t>{{C5_6_TERRAIN}}</a:t>
-            </a:r>
-          </a:p>
-          <a:p>
-            <a:pPr algn="ctr"/>
-            <a:endParaRPr lang="fr-FR" sz="1100" b="1" dirty="0">
-              <a:solidFill>
-                <a:schemeClr val="bg1"/>
-              </a:solidFill>
-              <a:latin typeface="Noto Sans" panose="020B0502040504020204" pitchFamily="34" charset="0"/>
-              <a:ea typeface="Noto Sans" panose="020B0502040504020204" pitchFamily="34" charset="0"/>
-              <a:cs typeface="Noto Sans" panose="020B0502040504020204" pitchFamily="34" charset="0"/>
-            </a:endParaRPr>
-          </a:p>
-        </p:txBody>
-      </p:sp>
-      <p:sp>
-        <p:nvSpPr>
-          <p:cNvPr id="121" name="ZoneTexte 120">
-            <a:extLst>
-              <a:ext uri="{FF2B5EF4-FFF2-40B4-BE49-F238E27FC236}">
-                <a16:creationId xmlns:a16="http://schemas.microsoft.com/office/drawing/2014/main" id="{F4652EAC-16B7-2042-AB26-E5DE4DBD1890}"/>
-              </a:ext>
-            </a:extLst>
-          </p:cNvPr>
-          <p:cNvSpPr txBox="1"/>
-          <p:nvPr/>
-        </p:nvSpPr>
-        <p:spPr>
-          <a:xfrm>
-            <a:off x="328655" y="3077888"/>
-            <a:ext cx="2730605" cy="430887"/>
-          </a:xfrm>
-          <a:prstGeom prst="rect">
-            <a:avLst/>
-          </a:prstGeom>
-          <a:noFill/>
-        </p:spPr>
-        <p:txBody>
-          <a:bodyPr wrap="square" rtlCol="0">
-            <a:spAutoFit/>
-          </a:bodyPr>
-          <a:lstStyle/>
-          <a:p>
-            <a:pPr algn="ctr"/>
-            <a:r>
-              <a:rPr lang="fr-FR" sz="1100" b="1" dirty="0">
-                <a:solidFill>
-                  <a:schemeClr val="bg1"/>
-                </a:solidFill>
-                <a:latin typeface="Noto Sans" panose="020B0502040504020204" pitchFamily="34" charset="0"/>
-                <a:ea typeface="Noto Sans" panose="020B0502040504020204" pitchFamily="34" charset="0"/>
-                <a:cs typeface="Noto Sans" panose="020B0502040504020204" pitchFamily="34" charset="0"/>
-              </a:rPr>
-              <a:t>{{C7_8_TERRAIN}}</a:t>
-            </a:r>
-          </a:p>
-          <a:p>
-            <a:pPr algn="ctr"/>
-            <a:endParaRPr lang="fr-FR" sz="1100" b="1" dirty="0">
-              <a:solidFill>
-                <a:schemeClr val="bg1"/>
-              </a:solidFill>
-              <a:latin typeface="Noto Sans" panose="020B0502040504020204" pitchFamily="34" charset="0"/>
-              <a:ea typeface="Noto Sans" panose="020B0502040504020204" pitchFamily="34" charset="0"/>
-              <a:cs typeface="Noto Sans" panose="020B0502040504020204" pitchFamily="34" charset="0"/>
-            </a:endParaRPr>
-          </a:p>
-        </p:txBody>
-      </p:sp>
-      <p:sp>
-        <p:nvSpPr>
-          <p:cNvPr id="99" name="ZoneTexte 98">
-            <a:extLst>
-              <a:ext uri="{FF2B5EF4-FFF2-40B4-BE49-F238E27FC236}">
-                <a16:creationId xmlns:a16="http://schemas.microsoft.com/office/drawing/2014/main" id="{48AD87D9-18D0-B640-BD6D-41EEB45F11B2}"/>
-              </a:ext>
-            </a:extLst>
-          </p:cNvPr>
-          <p:cNvSpPr txBox="1"/>
-          <p:nvPr/>
-        </p:nvSpPr>
-        <p:spPr>
-          <a:xfrm>
-            <a:off x="3558612" y="4589655"/>
-            <a:ext cx="2770523" cy="430887"/>
-          </a:xfrm>
-          <a:prstGeom prst="rect">
-            <a:avLst/>
-          </a:prstGeom>
-          <a:noFill/>
-        </p:spPr>
-        <p:txBody>
-          <a:bodyPr wrap="square" rtlCol="0">
-            <a:spAutoFit/>
-          </a:bodyPr>
-          <a:lstStyle/>
-          <a:p>
-            <a:pPr algn="ctr"/>
-            <a:r>
-              <a:rPr lang="fr-FR" sz="1100" b="1" dirty="0">
-                <a:solidFill>
-                  <a:schemeClr val="bg1"/>
-                </a:solidFill>
-                <a:latin typeface="Noto Sans" panose="020B0502040504020204" pitchFamily="34" charset="0"/>
-                <a:ea typeface="Noto Sans" panose="020B0502040504020204" pitchFamily="34" charset="0"/>
-                <a:cs typeface="Noto Sans" panose="020B0502040504020204" pitchFamily="34" charset="0"/>
-              </a:rPr>
-              <a:t>{{C5_8_2_TERRAIN}}</a:t>
-            </a:r>
-          </a:p>
-          <a:p>
-            <a:pPr algn="ctr"/>
-            <a:endParaRPr lang="fr-FR" sz="1100" b="1" dirty="0">
-              <a:solidFill>
-                <a:schemeClr val="bg1"/>
-              </a:solidFill>
-              <a:latin typeface="Noto Sans" panose="020B0502040504020204" pitchFamily="34" charset="0"/>
-              <a:ea typeface="Noto Sans" panose="020B0502040504020204" pitchFamily="34" charset="0"/>
-              <a:cs typeface="Noto Sans" panose="020B0502040504020204" pitchFamily="34" charset="0"/>
-            </a:endParaRPr>
-          </a:p>
-        </p:txBody>
-      </p:sp>
-      <p:sp>
-        <p:nvSpPr>
-          <p:cNvPr id="83" name="ZoneTexte 82">
-            <a:extLst>
-              <a:ext uri="{FF2B5EF4-FFF2-40B4-BE49-F238E27FC236}">
-                <a16:creationId xmlns:a16="http://schemas.microsoft.com/office/drawing/2014/main" id="{590F566A-D92F-5242-BBDC-F144A710434C}"/>
-              </a:ext>
-            </a:extLst>
-          </p:cNvPr>
-          <p:cNvSpPr txBox="1"/>
-          <p:nvPr/>
-        </p:nvSpPr>
-        <p:spPr>
-          <a:xfrm>
-            <a:off x="3563176" y="1446132"/>
-            <a:ext cx="2770524" cy="430887"/>
-          </a:xfrm>
-          <a:prstGeom prst="rect">
-            <a:avLst/>
-          </a:prstGeom>
-          <a:noFill/>
-        </p:spPr>
-        <p:txBody>
-          <a:bodyPr wrap="square" rtlCol="0">
-            <a:spAutoFit/>
-          </a:bodyPr>
-          <a:lstStyle/>
-          <a:p>
-            <a:pPr algn="ctr"/>
-            <a:r>
-              <a:rPr lang="fr-FR" sz="1100" b="1" dirty="0">
-                <a:solidFill>
-                  <a:schemeClr val="bg1"/>
-                </a:solidFill>
-                <a:latin typeface="Noto Sans" panose="020B0502040504020204" pitchFamily="34" charset="0"/>
-                <a:ea typeface="Noto Sans" panose="020B0502040504020204" pitchFamily="34" charset="0"/>
-                <a:cs typeface="Noto Sans" panose="020B0502040504020204" pitchFamily="34" charset="0"/>
-              </a:rPr>
-              <a:t>{{C5_8_1_TERRAIN}}</a:t>
-            </a:r>
-          </a:p>
-          <a:p>
-            <a:pPr algn="ctr"/>
-            <a:endParaRPr lang="fr-FR" sz="1100" b="1" dirty="0">
-              <a:solidFill>
-                <a:schemeClr val="bg1"/>
-              </a:solidFill>
-              <a:latin typeface="Noto Sans" panose="020B0502040504020204" pitchFamily="34" charset="0"/>
-              <a:ea typeface="Noto Sans" panose="020B0502040504020204" pitchFamily="34" charset="0"/>
-              <a:cs typeface="Noto Sans" panose="020B0502040504020204" pitchFamily="34" charset="0"/>
-            </a:endParaRPr>
-          </a:p>
-        </p:txBody>
-      </p:sp>
-      <p:sp>
-        <p:nvSpPr>
-          <p:cNvPr id="75" name="Rounded Rectangle 2">
-            <a:extLst>
-              <a:ext uri="{FF2B5EF4-FFF2-40B4-BE49-F238E27FC236}">
-                <a16:creationId xmlns:a16="http://schemas.microsoft.com/office/drawing/2014/main" id="{09E25820-F75D-F44E-8354-F6B818527754}"/>
-              </a:ext>
-            </a:extLst>
-          </p:cNvPr>
-          <p:cNvSpPr/>
-          <p:nvPr/>
-        </p:nvSpPr>
-        <p:spPr>
-          <a:xfrm>
-            <a:off x="6807230" y="3048633"/>
+            <a:off x="3563555" y="1430524"/>
             <a:ext cx="2772945" cy="265527"/>
           </a:xfrm>
           <a:custGeom>
@@ -25810,6 +25594,222 @@
               <a:defRPr sz="1000"/>
             </a:pPr>
             <a:endParaRPr sz="907" dirty="0"/>
+          </a:p>
+        </p:txBody>
+      </p:sp>
+      <p:sp>
+        <p:nvSpPr>
+          <p:cNvPr id="143" name="ZoneTexte 142">
+            <a:extLst>
+              <a:ext uri="{FF2B5EF4-FFF2-40B4-BE49-F238E27FC236}">
+                <a16:creationId xmlns:a16="http://schemas.microsoft.com/office/drawing/2014/main" id="{910BFB0A-ECDD-4B46-9FD8-3FCF5E218450}"/>
+              </a:ext>
+            </a:extLst>
+          </p:cNvPr>
+          <p:cNvSpPr txBox="1"/>
+          <p:nvPr/>
+        </p:nvSpPr>
+        <p:spPr>
+          <a:xfrm>
+            <a:off x="7440224" y="3063383"/>
+            <a:ext cx="1414793" cy="430887"/>
+          </a:xfrm>
+          <a:prstGeom prst="rect">
+            <a:avLst/>
+          </a:prstGeom>
+          <a:noFill/>
+        </p:spPr>
+        <p:txBody>
+          <a:bodyPr wrap="square" rtlCol="0">
+            <a:spAutoFit/>
+          </a:bodyPr>
+          <a:lstStyle/>
+          <a:p>
+            <a:pPr algn="ctr"/>
+            <a:r>
+              <a:rPr lang="fr-FR" sz="1100" b="1" dirty="0">
+                <a:solidFill>
+                  <a:schemeClr val="bg1"/>
+                </a:solidFill>
+                <a:latin typeface="Noto Sans" panose="020B0502040504020204" pitchFamily="34" charset="0"/>
+                <a:ea typeface="Noto Sans" panose="020B0502040504020204" pitchFamily="34" charset="0"/>
+                <a:cs typeface="Noto Sans" panose="020B0502040504020204" pitchFamily="34" charset="0"/>
+              </a:rPr>
+              <a:t>{{C5_6_TERRAIN}}</a:t>
+            </a:r>
+          </a:p>
+          <a:p>
+            <a:pPr algn="ctr"/>
+            <a:endParaRPr lang="fr-FR" sz="1100" b="1" dirty="0">
+              <a:solidFill>
+                <a:schemeClr val="bg1"/>
+              </a:solidFill>
+              <a:latin typeface="Noto Sans" panose="020B0502040504020204" pitchFamily="34" charset="0"/>
+              <a:ea typeface="Noto Sans" panose="020B0502040504020204" pitchFamily="34" charset="0"/>
+              <a:cs typeface="Noto Sans" panose="020B0502040504020204" pitchFamily="34" charset="0"/>
+            </a:endParaRPr>
+          </a:p>
+        </p:txBody>
+      </p:sp>
+      <p:sp>
+        <p:nvSpPr>
+          <p:cNvPr id="121" name="ZoneTexte 120">
+            <a:extLst>
+              <a:ext uri="{FF2B5EF4-FFF2-40B4-BE49-F238E27FC236}">
+                <a16:creationId xmlns:a16="http://schemas.microsoft.com/office/drawing/2014/main" id="{F4652EAC-16B7-2042-AB26-E5DE4DBD1890}"/>
+              </a:ext>
+            </a:extLst>
+          </p:cNvPr>
+          <p:cNvSpPr txBox="1"/>
+          <p:nvPr/>
+        </p:nvSpPr>
+        <p:spPr>
+          <a:xfrm>
+            <a:off x="328655" y="3077888"/>
+            <a:ext cx="2730605" cy="430887"/>
+          </a:xfrm>
+          <a:prstGeom prst="rect">
+            <a:avLst/>
+          </a:prstGeom>
+          <a:noFill/>
+        </p:spPr>
+        <p:txBody>
+          <a:bodyPr wrap="square" rtlCol="0">
+            <a:spAutoFit/>
+          </a:bodyPr>
+          <a:lstStyle/>
+          <a:p>
+            <a:pPr algn="ctr"/>
+            <a:r>
+              <a:rPr lang="fr-FR" sz="1100" b="1" dirty="0">
+                <a:solidFill>
+                  <a:schemeClr val="bg1"/>
+                </a:solidFill>
+                <a:latin typeface="Noto Sans" panose="020B0502040504020204" pitchFamily="34" charset="0"/>
+                <a:ea typeface="Noto Sans" panose="020B0502040504020204" pitchFamily="34" charset="0"/>
+                <a:cs typeface="Noto Sans" panose="020B0502040504020204" pitchFamily="34" charset="0"/>
+              </a:rPr>
+              <a:t>{{C7_8_TERRAIN}}</a:t>
+            </a:r>
+          </a:p>
+          <a:p>
+            <a:pPr algn="ctr"/>
+            <a:endParaRPr lang="fr-FR" sz="1100" b="1" dirty="0">
+              <a:solidFill>
+                <a:schemeClr val="bg1"/>
+              </a:solidFill>
+              <a:latin typeface="Noto Sans" panose="020B0502040504020204" pitchFamily="34" charset="0"/>
+              <a:ea typeface="Noto Sans" panose="020B0502040504020204" pitchFamily="34" charset="0"/>
+              <a:cs typeface="Noto Sans" panose="020B0502040504020204" pitchFamily="34" charset="0"/>
+            </a:endParaRPr>
+          </a:p>
+        </p:txBody>
+      </p:sp>
+      <p:sp>
+        <p:nvSpPr>
+          <p:cNvPr id="99" name="ZoneTexte 98">
+            <a:extLst>
+              <a:ext uri="{FF2B5EF4-FFF2-40B4-BE49-F238E27FC236}">
+                <a16:creationId xmlns:a16="http://schemas.microsoft.com/office/drawing/2014/main" id="{48AD87D9-18D0-B640-BD6D-41EEB45F11B2}"/>
+              </a:ext>
+            </a:extLst>
+          </p:cNvPr>
+          <p:cNvSpPr txBox="1"/>
+          <p:nvPr/>
+        </p:nvSpPr>
+        <p:spPr>
+          <a:xfrm>
+            <a:off x="3558612" y="4589655"/>
+            <a:ext cx="2770523" cy="430887"/>
+          </a:xfrm>
+          <a:prstGeom prst="rect">
+            <a:avLst/>
+          </a:prstGeom>
+          <a:noFill/>
+        </p:spPr>
+        <p:txBody>
+          <a:bodyPr wrap="square" rtlCol="0">
+            <a:spAutoFit/>
+          </a:bodyPr>
+          <a:lstStyle/>
+          <a:p>
+            <a:pPr algn="ctr"/>
+            <a:r>
+              <a:rPr lang="fr-FR" sz="1100" b="1" dirty="0">
+                <a:solidFill>
+                  <a:schemeClr val="bg1"/>
+                </a:solidFill>
+                <a:latin typeface="Noto Sans" panose="020B0502040504020204" pitchFamily="34" charset="0"/>
+                <a:ea typeface="Noto Sans" panose="020B0502040504020204" pitchFamily="34" charset="0"/>
+                <a:cs typeface="Noto Sans" panose="020B0502040504020204" pitchFamily="34" charset="0"/>
+              </a:rPr>
+              <a:t>{{C5_8_2_TERRAIN}}</a:t>
+            </a:r>
+          </a:p>
+          <a:p>
+            <a:pPr algn="ctr"/>
+            <a:endParaRPr lang="fr-FR" sz="1100" b="1" dirty="0">
+              <a:solidFill>
+                <a:schemeClr val="bg1"/>
+              </a:solidFill>
+              <a:latin typeface="Noto Sans" panose="020B0502040504020204" pitchFamily="34" charset="0"/>
+              <a:ea typeface="Noto Sans" panose="020B0502040504020204" pitchFamily="34" charset="0"/>
+              <a:cs typeface="Noto Sans" panose="020B0502040504020204" pitchFamily="34" charset="0"/>
+            </a:endParaRPr>
+          </a:p>
+        </p:txBody>
+      </p:sp>
+      <p:sp>
+        <p:nvSpPr>
+          <p:cNvPr id="83" name="ZoneTexte 82">
+            <a:extLst>
+              <a:ext uri="{FF2B5EF4-FFF2-40B4-BE49-F238E27FC236}">
+                <a16:creationId xmlns:a16="http://schemas.microsoft.com/office/drawing/2014/main" id="{590F566A-D92F-5242-BBDC-F144A710434C}"/>
+              </a:ext>
+            </a:extLst>
+          </p:cNvPr>
+          <p:cNvSpPr txBox="1"/>
+          <p:nvPr/>
+        </p:nvSpPr>
+        <p:spPr>
+          <a:xfrm>
+            <a:off x="3563176" y="1446132"/>
+            <a:ext cx="2770524" cy="430887"/>
+          </a:xfrm>
+          <a:prstGeom prst="rect">
+            <a:avLst/>
+          </a:prstGeom>
+          <a:noFill/>
+        </p:spPr>
+        <p:txBody>
+          <a:bodyPr wrap="square" rtlCol="0">
+            <a:spAutoFit/>
+          </a:bodyPr>
+          <a:lstStyle/>
+          <a:p>
+            <a:pPr algn="ctr"/>
+            <a:r>
+              <a:rPr lang="fr-FR" sz="1100" b="1" dirty="0">
+                <a:solidFill>
+                  <a:schemeClr val="bg1"/>
+                </a:solidFill>
+                <a:latin typeface="Noto Sans" panose="020B0502040504020204" pitchFamily="34" charset="0"/>
+                <a:ea typeface="Noto Sans" panose="020B0502040504020204" pitchFamily="34" charset="0"/>
+                <a:cs typeface="Noto Sans" panose="020B0502040504020204" pitchFamily="34" charset="0"/>
+              </a:rPr>
+              <a:t>{{C5_8_1_TERRAIN}}</a:t>
+            </a:r>
+          </a:p>
+          <a:p>
+            <a:pPr algn="ctr"/>
+            <a:endParaRPr lang="fr-FR" sz="1100" b="1" dirty="0">
+              <a:solidFill>
+                <a:schemeClr val="bg1"/>
+              </a:solidFill>
+              <a:latin typeface="Noto Sans" panose="020B0502040504020204" pitchFamily="34" charset="0"/>
+              <a:ea typeface="Noto Sans" panose="020B0502040504020204" pitchFamily="34" charset="0"/>
+              <a:cs typeface="Noto Sans" panose="020B0502040504020204" pitchFamily="34" charset="0"/>
+            </a:endParaRPr>
           </a:p>
         </p:txBody>
       </p:sp>

</xml_diff>